<commit_message>
build: Vorlage, Episode 2 und Seite mit Video-Kreis neu gebaut
30 von 31 Folien und 19 von 20 Galerie-Folien zeigen jetzt den Kreis mit Brustbild (nicht die Titelfolie).
check_deck ohne Befund, validate.py bestanden.

Co-Authored-By: Claude Opus 5.5 <noreply@anthropic.com>
Claude-Session: https://claude.ai/code/session_01N9PVtcZKjnuaWVKADDArAR
</commit_message>
<xml_diff>
--- a/site/downloads/flaesh-campus-in-office-whitening-workflow.pptx
+++ b/site/downloads/flaesh-campus-in-office-whitening-workflow.pptx
@@ -4200,7 +4200,69 @@
       </p:pic>
       <p:sp>
         <p:nvSpPr>
-          <p:cNvPr id="5" name="Episode"/>
+          <p:cNvPr id="5" name="zone-ring"/>
+          <p:cNvSpPr/>
+          <p:nvPr/>
+        </p:nvSpPr>
+        <p:spPr>
+          <a:xfrm>
+            <a:off x="9931400" y="4597400"/>
+            <a:ext cx="1905000" cy="1905000"/>
+          </a:xfrm>
+          <a:prstGeom prst="ellipse">
+            <a:avLst/>
+          </a:prstGeom>
+          <a:solidFill>
+            <a:srgbClr val="FFFFFF"/>
+          </a:solidFill>
+          <a:ln w="25400">
+            <a:solidFill>
+              <a:srgbClr val="00A5FF"/>
+            </a:solidFill>
+          </a:ln>
+          <a:effectLst>
+            <a:glow rad="292100">
+              <a:srgbClr val="00A5FF">
+                <a:alpha val="45000"/>
+              </a:srgbClr>
+            </a:glow>
+          </a:effectLst>
+        </p:spPr>
+        <p:txBody>
+          <a:bodyPr rtlCol="0" anchor="ctr"/>
+          <a:lstStyle/>
+          <a:p>
+            <a:pPr algn="ctr"/>
+          </a:p>
+        </p:txBody>
+      </p:sp>
+      <p:pic>
+        <p:nvPicPr>
+          <p:cNvPr id="6" name="zone-presenter" descr="video-presenter.jpg"/>
+          <p:cNvPicPr>
+            <a:picLocks noChangeAspect="1"/>
+          </p:cNvPicPr>
+          <p:nvPr/>
+        </p:nvPicPr>
+        <p:blipFill>
+          <a:blip r:embed="rId3"/>
+          <a:stretch>
+            <a:fillRect/>
+          </a:stretch>
+        </p:blipFill>
+        <p:spPr>
+          <a:xfrm>
+            <a:off x="9956800" y="4622800"/>
+            <a:ext cx="1854200" cy="1854200"/>
+          </a:xfrm>
+          <a:prstGeom prst="ellipse">
+            <a:avLst/>
+          </a:prstGeom>
+        </p:spPr>
+      </p:pic>
+      <p:sp>
+        <p:nvSpPr>
+          <p:cNvPr id="7" name="Episode"/>
           <p:cNvSpPr>
             <a:spLocks noGrp="1"/>
           </p:cNvSpPr>
@@ -4254,7 +4316,7 @@
       </p:sp>
       <p:sp>
         <p:nvSpPr>
-          <p:cNvPr id="6" name="Kicker"/>
+          <p:cNvPr id="8" name="Kicker"/>
           <p:cNvSpPr>
             <a:spLocks noGrp="1"/>
           </p:cNvSpPr>
@@ -4308,7 +4370,7 @@
       </p:sp>
       <p:sp>
         <p:nvSpPr>
-          <p:cNvPr id="7" name="Title"/>
+          <p:cNvPr id="9" name="Title"/>
           <p:cNvSpPr>
             <a:spLocks noGrp="1"/>
           </p:cNvSpPr>
@@ -4483,7 +4545,69 @@
       </p:pic>
       <p:sp>
         <p:nvSpPr>
-          <p:cNvPr id="5" name="Episode"/>
+          <p:cNvPr id="5" name="zone-ring"/>
+          <p:cNvSpPr/>
+          <p:nvPr/>
+        </p:nvSpPr>
+        <p:spPr>
+          <a:xfrm>
+            <a:off x="9931400" y="4597400"/>
+            <a:ext cx="1905000" cy="1905000"/>
+          </a:xfrm>
+          <a:prstGeom prst="ellipse">
+            <a:avLst/>
+          </a:prstGeom>
+          <a:solidFill>
+            <a:srgbClr val="FFFFFF"/>
+          </a:solidFill>
+          <a:ln w="25400">
+            <a:solidFill>
+              <a:srgbClr val="00A5FF"/>
+            </a:solidFill>
+          </a:ln>
+          <a:effectLst>
+            <a:glow rad="292100">
+              <a:srgbClr val="00A5FF">
+                <a:alpha val="45000"/>
+              </a:srgbClr>
+            </a:glow>
+          </a:effectLst>
+        </p:spPr>
+        <p:txBody>
+          <a:bodyPr rtlCol="0" anchor="ctr"/>
+          <a:lstStyle/>
+          <a:p>
+            <a:pPr algn="ctr"/>
+          </a:p>
+        </p:txBody>
+      </p:sp>
+      <p:pic>
+        <p:nvPicPr>
+          <p:cNvPr id="6" name="zone-presenter" descr="video-presenter.jpg"/>
+          <p:cNvPicPr>
+            <a:picLocks noChangeAspect="1"/>
+          </p:cNvPicPr>
+          <p:nvPr/>
+        </p:nvPicPr>
+        <p:blipFill>
+          <a:blip r:embed="rId3"/>
+          <a:stretch>
+            <a:fillRect/>
+          </a:stretch>
+        </p:blipFill>
+        <p:spPr>
+          <a:xfrm>
+            <a:off x="9956800" y="4622800"/>
+            <a:ext cx="1854200" cy="1854200"/>
+          </a:xfrm>
+          <a:prstGeom prst="ellipse">
+            <a:avLst/>
+          </a:prstGeom>
+        </p:spPr>
+      </p:pic>
+      <p:sp>
+        <p:nvSpPr>
+          <p:cNvPr id="7" name="Episode"/>
           <p:cNvSpPr>
             <a:spLocks noGrp="1"/>
           </p:cNvSpPr>
@@ -4537,7 +4661,7 @@
       </p:sp>
       <p:sp>
         <p:nvSpPr>
-          <p:cNvPr id="6" name="Kicker"/>
+          <p:cNvPr id="8" name="Kicker"/>
           <p:cNvSpPr>
             <a:spLocks noGrp="1"/>
           </p:cNvSpPr>
@@ -4591,7 +4715,7 @@
       </p:sp>
       <p:sp>
         <p:nvSpPr>
-          <p:cNvPr id="7" name="Title"/>
+          <p:cNvPr id="9" name="Title"/>
           <p:cNvSpPr>
             <a:spLocks noGrp="1"/>
           </p:cNvSpPr>
@@ -4766,7 +4890,69 @@
       </p:pic>
       <p:sp>
         <p:nvSpPr>
-          <p:cNvPr id="5" name="Episode"/>
+          <p:cNvPr id="5" name="zone-ring"/>
+          <p:cNvSpPr/>
+          <p:nvPr/>
+        </p:nvSpPr>
+        <p:spPr>
+          <a:xfrm>
+            <a:off x="9931400" y="4597400"/>
+            <a:ext cx="1905000" cy="1905000"/>
+          </a:xfrm>
+          <a:prstGeom prst="ellipse">
+            <a:avLst/>
+          </a:prstGeom>
+          <a:solidFill>
+            <a:srgbClr val="FFFFFF"/>
+          </a:solidFill>
+          <a:ln w="25400">
+            <a:solidFill>
+              <a:srgbClr val="00A5FF"/>
+            </a:solidFill>
+          </a:ln>
+          <a:effectLst>
+            <a:glow rad="292100">
+              <a:srgbClr val="00A5FF">
+                <a:alpha val="45000"/>
+              </a:srgbClr>
+            </a:glow>
+          </a:effectLst>
+        </p:spPr>
+        <p:txBody>
+          <a:bodyPr rtlCol="0" anchor="ctr"/>
+          <a:lstStyle/>
+          <a:p>
+            <a:pPr algn="ctr"/>
+          </a:p>
+        </p:txBody>
+      </p:sp>
+      <p:pic>
+        <p:nvPicPr>
+          <p:cNvPr id="6" name="zone-presenter" descr="video-presenter.jpg"/>
+          <p:cNvPicPr>
+            <a:picLocks noChangeAspect="1"/>
+          </p:cNvPicPr>
+          <p:nvPr/>
+        </p:nvPicPr>
+        <p:blipFill>
+          <a:blip r:embed="rId3"/>
+          <a:stretch>
+            <a:fillRect/>
+          </a:stretch>
+        </p:blipFill>
+        <p:spPr>
+          <a:xfrm>
+            <a:off x="9956800" y="4622800"/>
+            <a:ext cx="1854200" cy="1854200"/>
+          </a:xfrm>
+          <a:prstGeom prst="ellipse">
+            <a:avLst/>
+          </a:prstGeom>
+        </p:spPr>
+      </p:pic>
+      <p:sp>
+        <p:nvSpPr>
+          <p:cNvPr id="7" name="Episode"/>
           <p:cNvSpPr>
             <a:spLocks noGrp="1"/>
           </p:cNvSpPr>
@@ -4820,7 +5006,7 @@
       </p:sp>
       <p:sp>
         <p:nvSpPr>
-          <p:cNvPr id="6" name="Kicker"/>
+          <p:cNvPr id="8" name="Kicker"/>
           <p:cNvSpPr>
             <a:spLocks noGrp="1"/>
           </p:cNvSpPr>
@@ -4874,7 +5060,7 @@
       </p:sp>
       <p:sp>
         <p:nvSpPr>
-          <p:cNvPr id="7" name="Title"/>
+          <p:cNvPr id="9" name="Title"/>
           <p:cNvSpPr>
             <a:spLocks noGrp="1"/>
           </p:cNvSpPr>
@@ -4928,7 +5114,7 @@
       </p:sp>
       <p:sp>
         <p:nvSpPr>
-          <p:cNvPr id="8" name="Points"/>
+          <p:cNvPr id="10" name="Points"/>
           <p:cNvSpPr>
             <a:spLocks noGrp="1"/>
           </p:cNvSpPr>
@@ -5130,7 +5316,69 @@
       </p:pic>
       <p:sp>
         <p:nvSpPr>
-          <p:cNvPr id="5" name="Episode"/>
+          <p:cNvPr id="5" name="zone-ring"/>
+          <p:cNvSpPr/>
+          <p:nvPr/>
+        </p:nvSpPr>
+        <p:spPr>
+          <a:xfrm>
+            <a:off x="9931400" y="4597400"/>
+            <a:ext cx="1905000" cy="1905000"/>
+          </a:xfrm>
+          <a:prstGeom prst="ellipse">
+            <a:avLst/>
+          </a:prstGeom>
+          <a:solidFill>
+            <a:srgbClr val="FFFFFF"/>
+          </a:solidFill>
+          <a:ln w="25400">
+            <a:solidFill>
+              <a:srgbClr val="00A5FF"/>
+            </a:solidFill>
+          </a:ln>
+          <a:effectLst>
+            <a:glow rad="292100">
+              <a:srgbClr val="00A5FF">
+                <a:alpha val="45000"/>
+              </a:srgbClr>
+            </a:glow>
+          </a:effectLst>
+        </p:spPr>
+        <p:txBody>
+          <a:bodyPr rtlCol="0" anchor="ctr"/>
+          <a:lstStyle/>
+          <a:p>
+            <a:pPr algn="ctr"/>
+          </a:p>
+        </p:txBody>
+      </p:sp>
+      <p:pic>
+        <p:nvPicPr>
+          <p:cNvPr id="6" name="zone-presenter" descr="video-presenter.jpg"/>
+          <p:cNvPicPr>
+            <a:picLocks noChangeAspect="1"/>
+          </p:cNvPicPr>
+          <p:nvPr/>
+        </p:nvPicPr>
+        <p:blipFill>
+          <a:blip r:embed="rId3"/>
+          <a:stretch>
+            <a:fillRect/>
+          </a:stretch>
+        </p:blipFill>
+        <p:spPr>
+          <a:xfrm>
+            <a:off x="9956800" y="4622800"/>
+            <a:ext cx="1854200" cy="1854200"/>
+          </a:xfrm>
+          <a:prstGeom prst="ellipse">
+            <a:avLst/>
+          </a:prstGeom>
+        </p:spPr>
+      </p:pic>
+      <p:sp>
+        <p:nvSpPr>
+          <p:cNvPr id="7" name="Episode"/>
           <p:cNvSpPr>
             <a:spLocks noGrp="1"/>
           </p:cNvSpPr>
@@ -5184,7 +5432,7 @@
       </p:sp>
       <p:sp>
         <p:nvSpPr>
-          <p:cNvPr id="6" name="Kicker"/>
+          <p:cNvPr id="8" name="Kicker"/>
           <p:cNvSpPr>
             <a:spLocks noGrp="1"/>
           </p:cNvSpPr>
@@ -5238,7 +5486,7 @@
       </p:sp>
       <p:sp>
         <p:nvSpPr>
-          <p:cNvPr id="7" name="Title"/>
+          <p:cNvPr id="9" name="Title"/>
           <p:cNvSpPr>
             <a:spLocks noGrp="1"/>
           </p:cNvSpPr>
@@ -5812,7 +6060,69 @@
       </p:pic>
       <p:sp>
         <p:nvSpPr>
-          <p:cNvPr id="5" name="Episode"/>
+          <p:cNvPr id="5" name="zone-ring"/>
+          <p:cNvSpPr/>
+          <p:nvPr/>
+        </p:nvSpPr>
+        <p:spPr>
+          <a:xfrm>
+            <a:off x="9931400" y="4597400"/>
+            <a:ext cx="1905000" cy="1905000"/>
+          </a:xfrm>
+          <a:prstGeom prst="ellipse">
+            <a:avLst/>
+          </a:prstGeom>
+          <a:solidFill>
+            <a:srgbClr val="FFFFFF"/>
+          </a:solidFill>
+          <a:ln w="25400">
+            <a:solidFill>
+              <a:srgbClr val="00A5FF"/>
+            </a:solidFill>
+          </a:ln>
+          <a:effectLst>
+            <a:glow rad="292100">
+              <a:srgbClr val="00A5FF">
+                <a:alpha val="45000"/>
+              </a:srgbClr>
+            </a:glow>
+          </a:effectLst>
+        </p:spPr>
+        <p:txBody>
+          <a:bodyPr rtlCol="0" anchor="ctr"/>
+          <a:lstStyle/>
+          <a:p>
+            <a:pPr algn="ctr"/>
+          </a:p>
+        </p:txBody>
+      </p:sp>
+      <p:pic>
+        <p:nvPicPr>
+          <p:cNvPr id="6" name="zone-presenter" descr="video-presenter.jpg"/>
+          <p:cNvPicPr>
+            <a:picLocks noChangeAspect="1"/>
+          </p:cNvPicPr>
+          <p:nvPr/>
+        </p:nvPicPr>
+        <p:blipFill>
+          <a:blip r:embed="rId3"/>
+          <a:stretch>
+            <a:fillRect/>
+          </a:stretch>
+        </p:blipFill>
+        <p:spPr>
+          <a:xfrm>
+            <a:off x="9956800" y="4622800"/>
+            <a:ext cx="1854200" cy="1854200"/>
+          </a:xfrm>
+          <a:prstGeom prst="ellipse">
+            <a:avLst/>
+          </a:prstGeom>
+        </p:spPr>
+      </p:pic>
+      <p:sp>
+        <p:nvSpPr>
+          <p:cNvPr id="7" name="Episode"/>
           <p:cNvSpPr>
             <a:spLocks noGrp="1"/>
           </p:cNvSpPr>
@@ -5866,7 +6176,7 @@
       </p:sp>
       <p:sp>
         <p:nvSpPr>
-          <p:cNvPr id="6" name="Kicker"/>
+          <p:cNvPr id="8" name="Kicker"/>
           <p:cNvSpPr>
             <a:spLocks noGrp="1"/>
           </p:cNvSpPr>
@@ -5920,7 +6230,7 @@
       </p:sp>
       <p:sp>
         <p:nvSpPr>
-          <p:cNvPr id="7" name="Title"/>
+          <p:cNvPr id="9" name="Title"/>
           <p:cNvSpPr>
             <a:spLocks noGrp="1"/>
           </p:cNvSpPr>
@@ -5974,7 +6284,7 @@
       </p:sp>
       <p:sp>
         <p:nvSpPr>
-          <p:cNvPr id="8" name="PhotoBefore"/>
+          <p:cNvPr id="10" name="PhotoBefore"/>
           <p:cNvSpPr>
             <a:spLocks noGrp="1"/>
           </p:cNvSpPr>
@@ -6030,7 +6340,7 @@
       </p:sp>
       <p:sp>
         <p:nvSpPr>
-          <p:cNvPr id="9" name="PhotoAfter"/>
+          <p:cNvPr id="11" name="PhotoAfter"/>
           <p:cNvSpPr>
             <a:spLocks noGrp="1"/>
           </p:cNvSpPr>
@@ -6086,7 +6396,7 @@
       </p:sp>
       <p:sp>
         <p:nvSpPr>
-          <p:cNvPr id="10" name="LabelBefore"/>
+          <p:cNvPr id="12" name="LabelBefore"/>
           <p:cNvSpPr>
             <a:spLocks noGrp="1"/>
           </p:cNvSpPr>
@@ -6140,7 +6450,7 @@
       </p:sp>
       <p:sp>
         <p:nvSpPr>
-          <p:cNvPr id="11" name="LabelAfter"/>
+          <p:cNvPr id="13" name="LabelAfter"/>
           <p:cNvSpPr>
             <a:spLocks noGrp="1"/>
           </p:cNvSpPr>
@@ -6315,7 +6625,69 @@
       </p:pic>
       <p:sp>
         <p:nvSpPr>
-          <p:cNvPr id="5" name="Episode"/>
+          <p:cNvPr id="5" name="zone-ring"/>
+          <p:cNvSpPr/>
+          <p:nvPr/>
+        </p:nvSpPr>
+        <p:spPr>
+          <a:xfrm>
+            <a:off x="9931400" y="4597400"/>
+            <a:ext cx="1905000" cy="1905000"/>
+          </a:xfrm>
+          <a:prstGeom prst="ellipse">
+            <a:avLst/>
+          </a:prstGeom>
+          <a:solidFill>
+            <a:srgbClr val="FFFFFF"/>
+          </a:solidFill>
+          <a:ln w="25400">
+            <a:solidFill>
+              <a:srgbClr val="00A5FF"/>
+            </a:solidFill>
+          </a:ln>
+          <a:effectLst>
+            <a:glow rad="292100">
+              <a:srgbClr val="00A5FF">
+                <a:alpha val="45000"/>
+              </a:srgbClr>
+            </a:glow>
+          </a:effectLst>
+        </p:spPr>
+        <p:txBody>
+          <a:bodyPr rtlCol="0" anchor="ctr"/>
+          <a:lstStyle/>
+          <a:p>
+            <a:pPr algn="ctr"/>
+          </a:p>
+        </p:txBody>
+      </p:sp>
+      <p:pic>
+        <p:nvPicPr>
+          <p:cNvPr id="6" name="zone-presenter" descr="video-presenter.jpg"/>
+          <p:cNvPicPr>
+            <a:picLocks noChangeAspect="1"/>
+          </p:cNvPicPr>
+          <p:nvPr/>
+        </p:nvPicPr>
+        <p:blipFill>
+          <a:blip r:embed="rId3"/>
+          <a:stretch>
+            <a:fillRect/>
+          </a:stretch>
+        </p:blipFill>
+        <p:spPr>
+          <a:xfrm>
+            <a:off x="9956800" y="4622800"/>
+            <a:ext cx="1854200" cy="1854200"/>
+          </a:xfrm>
+          <a:prstGeom prst="ellipse">
+            <a:avLst/>
+          </a:prstGeom>
+        </p:spPr>
+      </p:pic>
+      <p:sp>
+        <p:nvSpPr>
+          <p:cNvPr id="7" name="Episode"/>
           <p:cNvSpPr>
             <a:spLocks noGrp="1"/>
           </p:cNvSpPr>
@@ -6369,7 +6741,7 @@
       </p:sp>
       <p:sp>
         <p:nvSpPr>
-          <p:cNvPr id="6" name="Kicker"/>
+          <p:cNvPr id="8" name="Kicker"/>
           <p:cNvSpPr>
             <a:spLocks noGrp="1"/>
           </p:cNvSpPr>
@@ -6423,7 +6795,7 @@
       </p:sp>
       <p:sp>
         <p:nvSpPr>
-          <p:cNvPr id="7" name="Title"/>
+          <p:cNvPr id="9" name="Title"/>
           <p:cNvSpPr>
             <a:spLocks noGrp="1"/>
           </p:cNvSpPr>
@@ -6477,7 +6849,7 @@
       </p:sp>
       <p:sp>
         <p:nvSpPr>
-          <p:cNvPr id="8" name="Photo"/>
+          <p:cNvPr id="10" name="Photo"/>
           <p:cNvSpPr>
             <a:spLocks noGrp="1"/>
           </p:cNvSpPr>
@@ -6654,7 +7026,69 @@
       </p:pic>
       <p:sp>
         <p:nvSpPr>
-          <p:cNvPr id="5" name="Episode"/>
+          <p:cNvPr id="5" name="zone-ring"/>
+          <p:cNvSpPr/>
+          <p:nvPr/>
+        </p:nvSpPr>
+        <p:spPr>
+          <a:xfrm>
+            <a:off x="9931400" y="4597400"/>
+            <a:ext cx="1905000" cy="1905000"/>
+          </a:xfrm>
+          <a:prstGeom prst="ellipse">
+            <a:avLst/>
+          </a:prstGeom>
+          <a:solidFill>
+            <a:srgbClr val="FFFFFF"/>
+          </a:solidFill>
+          <a:ln w="25400">
+            <a:solidFill>
+              <a:srgbClr val="00A5FF"/>
+            </a:solidFill>
+          </a:ln>
+          <a:effectLst>
+            <a:glow rad="292100">
+              <a:srgbClr val="00A5FF">
+                <a:alpha val="45000"/>
+              </a:srgbClr>
+            </a:glow>
+          </a:effectLst>
+        </p:spPr>
+        <p:txBody>
+          <a:bodyPr rtlCol="0" anchor="ctr"/>
+          <a:lstStyle/>
+          <a:p>
+            <a:pPr algn="ctr"/>
+          </a:p>
+        </p:txBody>
+      </p:sp>
+      <p:pic>
+        <p:nvPicPr>
+          <p:cNvPr id="6" name="zone-presenter" descr="video-presenter.jpg"/>
+          <p:cNvPicPr>
+            <a:picLocks noChangeAspect="1"/>
+          </p:cNvPicPr>
+          <p:nvPr/>
+        </p:nvPicPr>
+        <p:blipFill>
+          <a:blip r:embed="rId3"/>
+          <a:stretch>
+            <a:fillRect/>
+          </a:stretch>
+        </p:blipFill>
+        <p:spPr>
+          <a:xfrm>
+            <a:off x="9956800" y="4622800"/>
+            <a:ext cx="1854200" cy="1854200"/>
+          </a:xfrm>
+          <a:prstGeom prst="ellipse">
+            <a:avLst/>
+          </a:prstGeom>
+        </p:spPr>
+      </p:pic>
+      <p:sp>
+        <p:nvSpPr>
+          <p:cNvPr id="7" name="Episode"/>
           <p:cNvSpPr>
             <a:spLocks noGrp="1"/>
           </p:cNvSpPr>
@@ -6708,7 +7142,7 @@
       </p:sp>
       <p:sp>
         <p:nvSpPr>
-          <p:cNvPr id="6" name="Kicker"/>
+          <p:cNvPr id="8" name="Kicker"/>
           <p:cNvSpPr>
             <a:spLocks noGrp="1"/>
           </p:cNvSpPr>
@@ -6762,7 +7196,7 @@
       </p:sp>
       <p:sp>
         <p:nvSpPr>
-          <p:cNvPr id="7" name="Title"/>
+          <p:cNvPr id="9" name="Title"/>
           <p:cNvSpPr>
             <a:spLocks noGrp="1"/>
           </p:cNvSpPr>
@@ -6816,7 +7250,7 @@
       </p:sp>
       <p:sp>
         <p:nvSpPr>
-          <p:cNvPr id="8" name="Story"/>
+          <p:cNvPr id="10" name="Story"/>
           <p:cNvSpPr>
             <a:spLocks noGrp="1"/>
           </p:cNvSpPr>
@@ -6991,7 +7425,69 @@
       </p:pic>
       <p:sp>
         <p:nvSpPr>
-          <p:cNvPr id="5" name="Episode"/>
+          <p:cNvPr id="5" name="zone-ring"/>
+          <p:cNvSpPr/>
+          <p:nvPr/>
+        </p:nvSpPr>
+        <p:spPr>
+          <a:xfrm>
+            <a:off x="9931400" y="4597400"/>
+            <a:ext cx="1905000" cy="1905000"/>
+          </a:xfrm>
+          <a:prstGeom prst="ellipse">
+            <a:avLst/>
+          </a:prstGeom>
+          <a:solidFill>
+            <a:srgbClr val="232C31"/>
+          </a:solidFill>
+          <a:ln w="25400">
+            <a:solidFill>
+              <a:srgbClr val="00A5FF"/>
+            </a:solidFill>
+          </a:ln>
+          <a:effectLst>
+            <a:glow rad="381000">
+              <a:srgbClr val="00A5FF">
+                <a:alpha val="55000"/>
+              </a:srgbClr>
+            </a:glow>
+          </a:effectLst>
+        </p:spPr>
+        <p:txBody>
+          <a:bodyPr rtlCol="0" anchor="ctr"/>
+          <a:lstStyle/>
+          <a:p>
+            <a:pPr algn="ctr"/>
+          </a:p>
+        </p:txBody>
+      </p:sp>
+      <p:pic>
+        <p:nvPicPr>
+          <p:cNvPr id="6" name="zone-presenter" descr="video-presenter.jpg"/>
+          <p:cNvPicPr>
+            <a:picLocks noChangeAspect="1"/>
+          </p:cNvPicPr>
+          <p:nvPr/>
+        </p:nvPicPr>
+        <p:blipFill>
+          <a:blip r:embed="rId3"/>
+          <a:stretch>
+            <a:fillRect/>
+          </a:stretch>
+        </p:blipFill>
+        <p:spPr>
+          <a:xfrm>
+            <a:off x="9956800" y="4622800"/>
+            <a:ext cx="1854200" cy="1854200"/>
+          </a:xfrm>
+          <a:prstGeom prst="ellipse">
+            <a:avLst/>
+          </a:prstGeom>
+        </p:spPr>
+      </p:pic>
+      <p:sp>
+        <p:nvSpPr>
+          <p:cNvPr id="7" name="Episode"/>
           <p:cNvSpPr>
             <a:spLocks noGrp="1"/>
           </p:cNvSpPr>
@@ -7045,7 +7541,7 @@
       </p:sp>
       <p:sp>
         <p:nvSpPr>
-          <p:cNvPr id="6" name="Kicker"/>
+          <p:cNvPr id="8" name="Kicker"/>
           <p:cNvSpPr>
             <a:spLocks noGrp="1"/>
           </p:cNvSpPr>
@@ -7099,7 +7595,7 @@
       </p:sp>
       <p:sp>
         <p:nvSpPr>
-          <p:cNvPr id="7" name="Question"/>
+          <p:cNvPr id="9" name="Question"/>
           <p:cNvSpPr>
             <a:spLocks noGrp="1"/>
           </p:cNvSpPr>
@@ -7322,7 +7818,69 @@
       </p:pic>
       <p:sp>
         <p:nvSpPr>
-          <p:cNvPr id="6" name="Episode"/>
+          <p:cNvPr id="6" name="zone-ring"/>
+          <p:cNvSpPr/>
+          <p:nvPr/>
+        </p:nvSpPr>
+        <p:spPr>
+          <a:xfrm>
+            <a:off x="9931400" y="4597400"/>
+            <a:ext cx="1905000" cy="1905000"/>
+          </a:xfrm>
+          <a:prstGeom prst="ellipse">
+            <a:avLst/>
+          </a:prstGeom>
+          <a:solidFill>
+            <a:srgbClr val="232C31"/>
+          </a:solidFill>
+          <a:ln w="25400">
+            <a:solidFill>
+              <a:srgbClr val="00A5FF"/>
+            </a:solidFill>
+          </a:ln>
+          <a:effectLst>
+            <a:glow rad="381000">
+              <a:srgbClr val="00A5FF">
+                <a:alpha val="55000"/>
+              </a:srgbClr>
+            </a:glow>
+          </a:effectLst>
+        </p:spPr>
+        <p:txBody>
+          <a:bodyPr rtlCol="0" anchor="ctr"/>
+          <a:lstStyle/>
+          <a:p>
+            <a:pPr algn="ctr"/>
+          </a:p>
+        </p:txBody>
+      </p:sp>
+      <p:pic>
+        <p:nvPicPr>
+          <p:cNvPr id="7" name="zone-presenter" descr="video-presenter.jpg"/>
+          <p:cNvPicPr>
+            <a:picLocks noChangeAspect="1"/>
+          </p:cNvPicPr>
+          <p:nvPr/>
+        </p:nvPicPr>
+        <p:blipFill>
+          <a:blip r:embed="rId3"/>
+          <a:stretch>
+            <a:fillRect/>
+          </a:stretch>
+        </p:blipFill>
+        <p:spPr>
+          <a:xfrm>
+            <a:off x="9956800" y="4622800"/>
+            <a:ext cx="1854200" cy="1854200"/>
+          </a:xfrm>
+          <a:prstGeom prst="ellipse">
+            <a:avLst/>
+          </a:prstGeom>
+        </p:spPr>
+      </p:pic>
+      <p:sp>
+        <p:nvSpPr>
+          <p:cNvPr id="8" name="Episode"/>
           <p:cNvSpPr>
             <a:spLocks noGrp="1"/>
           </p:cNvSpPr>
@@ -7376,7 +7934,7 @@
       </p:sp>
       <p:sp>
         <p:nvSpPr>
-          <p:cNvPr id="7" name="Number"/>
+          <p:cNvPr id="9" name="Number"/>
           <p:cNvSpPr>
             <a:spLocks noGrp="1"/>
           </p:cNvSpPr>
@@ -7440,7 +7998,7 @@
       </p:sp>
       <p:sp>
         <p:nvSpPr>
-          <p:cNvPr id="8" name="Kicker"/>
+          <p:cNvPr id="10" name="Kicker"/>
           <p:cNvSpPr>
             <a:spLocks noGrp="1"/>
           </p:cNvSpPr>
@@ -7494,7 +8052,7 @@
       </p:sp>
       <p:sp>
         <p:nvSpPr>
-          <p:cNvPr id="9" name="Title"/>
+          <p:cNvPr id="11" name="Title"/>
           <p:cNvSpPr>
             <a:spLocks noGrp="1"/>
           </p:cNvSpPr>
@@ -7551,7 +8109,7 @@
       </p:sp>
       <p:sp>
         <p:nvSpPr>
-          <p:cNvPr id="10" name="Line"/>
+          <p:cNvPr id="12" name="Line"/>
           <p:cNvSpPr>
             <a:spLocks noGrp="1"/>
           </p:cNvSpPr>
@@ -7726,7 +8284,69 @@
       </p:pic>
       <p:sp>
         <p:nvSpPr>
-          <p:cNvPr id="5" name="truth-card"/>
+          <p:cNvPr id="5" name="zone-ring"/>
+          <p:cNvSpPr/>
+          <p:nvPr/>
+        </p:nvSpPr>
+        <p:spPr>
+          <a:xfrm>
+            <a:off x="9931400" y="4597400"/>
+            <a:ext cx="1905000" cy="1905000"/>
+          </a:xfrm>
+          <a:prstGeom prst="ellipse">
+            <a:avLst/>
+          </a:prstGeom>
+          <a:solidFill>
+            <a:srgbClr val="232C31"/>
+          </a:solidFill>
+          <a:ln w="25400">
+            <a:solidFill>
+              <a:srgbClr val="00A5FF"/>
+            </a:solidFill>
+          </a:ln>
+          <a:effectLst>
+            <a:glow rad="381000">
+              <a:srgbClr val="00A5FF">
+                <a:alpha val="55000"/>
+              </a:srgbClr>
+            </a:glow>
+          </a:effectLst>
+        </p:spPr>
+        <p:txBody>
+          <a:bodyPr rtlCol="0" anchor="ctr"/>
+          <a:lstStyle/>
+          <a:p>
+            <a:pPr algn="ctr"/>
+          </a:p>
+        </p:txBody>
+      </p:sp>
+      <p:pic>
+        <p:nvPicPr>
+          <p:cNvPr id="6" name="zone-presenter" descr="video-presenter.jpg"/>
+          <p:cNvPicPr>
+            <a:picLocks noChangeAspect="1"/>
+          </p:cNvPicPr>
+          <p:nvPr/>
+        </p:nvPicPr>
+        <p:blipFill>
+          <a:blip r:embed="rId3"/>
+          <a:stretch>
+            <a:fillRect/>
+          </a:stretch>
+        </p:blipFill>
+        <p:spPr>
+          <a:xfrm>
+            <a:off x="9956800" y="4622800"/>
+            <a:ext cx="1854200" cy="1854200"/>
+          </a:xfrm>
+          <a:prstGeom prst="ellipse">
+            <a:avLst/>
+          </a:prstGeom>
+        </p:spPr>
+      </p:pic>
+      <p:sp>
+        <p:nvSpPr>
+          <p:cNvPr id="7" name="truth-card"/>
           <p:cNvSpPr/>
           <p:nvPr/>
         </p:nvSpPr>
@@ -7757,7 +8377,7 @@
       </p:sp>
       <p:sp>
         <p:nvSpPr>
-          <p:cNvPr id="6" name="answer-card"/>
+          <p:cNvPr id="8" name="answer-card"/>
           <p:cNvSpPr/>
           <p:nvPr/>
         </p:nvSpPr>
@@ -7797,7 +8417,7 @@
       </p:sp>
       <p:sp>
         <p:nvSpPr>
-          <p:cNvPr id="7" name="Episode"/>
+          <p:cNvPr id="9" name="Episode"/>
           <p:cNvSpPr>
             <a:spLocks noGrp="1"/>
           </p:cNvSpPr>
@@ -7851,7 +8471,7 @@
       </p:sp>
       <p:sp>
         <p:nvSpPr>
-          <p:cNvPr id="8" name="Kicker"/>
+          <p:cNvPr id="10" name="Kicker"/>
           <p:cNvSpPr>
             <a:spLocks noGrp="1"/>
           </p:cNvSpPr>
@@ -7905,7 +8525,7 @@
       </p:sp>
       <p:sp>
         <p:nvSpPr>
-          <p:cNvPr id="9" name="Quote"/>
+          <p:cNvPr id="11" name="Quote"/>
           <p:cNvSpPr>
             <a:spLocks noGrp="1"/>
           </p:cNvSpPr>
@@ -7959,7 +8579,7 @@
       </p:sp>
       <p:sp>
         <p:nvSpPr>
-          <p:cNvPr id="10" name="TruthLabel"/>
+          <p:cNvPr id="12" name="TruthLabel"/>
           <p:cNvSpPr>
             <a:spLocks noGrp="1"/>
           </p:cNvSpPr>
@@ -8013,7 +8633,7 @@
       </p:sp>
       <p:sp>
         <p:nvSpPr>
-          <p:cNvPr id="11" name="TruthText"/>
+          <p:cNvPr id="13" name="TruthText"/>
           <p:cNvSpPr>
             <a:spLocks noGrp="1"/>
           </p:cNvSpPr>
@@ -8067,7 +8687,7 @@
       </p:sp>
       <p:sp>
         <p:nvSpPr>
-          <p:cNvPr id="12" name="AnswerLabel"/>
+          <p:cNvPr id="14" name="AnswerLabel"/>
           <p:cNvSpPr>
             <a:spLocks noGrp="1"/>
           </p:cNvSpPr>
@@ -8121,7 +8741,7 @@
       </p:sp>
       <p:sp>
         <p:nvSpPr>
-          <p:cNvPr id="13" name="AnswerText"/>
+          <p:cNvPr id="15" name="AnswerText"/>
           <p:cNvSpPr>
             <a:spLocks noGrp="1"/>
           </p:cNvSpPr>
@@ -8296,7 +8916,69 @@
       </p:pic>
       <p:sp>
         <p:nvSpPr>
-          <p:cNvPr id="5" name="next-card"/>
+          <p:cNvPr id="5" name="zone-ring"/>
+          <p:cNvSpPr/>
+          <p:nvPr/>
+        </p:nvSpPr>
+        <p:spPr>
+          <a:xfrm>
+            <a:off x="9931400" y="4597400"/>
+            <a:ext cx="1905000" cy="1905000"/>
+          </a:xfrm>
+          <a:prstGeom prst="ellipse">
+            <a:avLst/>
+          </a:prstGeom>
+          <a:solidFill>
+            <a:srgbClr val="232C31"/>
+          </a:solidFill>
+          <a:ln w="25400">
+            <a:solidFill>
+              <a:srgbClr val="00A5FF"/>
+            </a:solidFill>
+          </a:ln>
+          <a:effectLst>
+            <a:glow rad="381000">
+              <a:srgbClr val="00A5FF">
+                <a:alpha val="55000"/>
+              </a:srgbClr>
+            </a:glow>
+          </a:effectLst>
+        </p:spPr>
+        <p:txBody>
+          <a:bodyPr rtlCol="0" anchor="ctr"/>
+          <a:lstStyle/>
+          <a:p>
+            <a:pPr algn="ctr"/>
+          </a:p>
+        </p:txBody>
+      </p:sp>
+      <p:pic>
+        <p:nvPicPr>
+          <p:cNvPr id="6" name="zone-presenter" descr="video-presenter.jpg"/>
+          <p:cNvPicPr>
+            <a:picLocks noChangeAspect="1"/>
+          </p:cNvPicPr>
+          <p:nvPr/>
+        </p:nvPicPr>
+        <p:blipFill>
+          <a:blip r:embed="rId3"/>
+          <a:stretch>
+            <a:fillRect/>
+          </a:stretch>
+        </p:blipFill>
+        <p:spPr>
+          <a:xfrm>
+            <a:off x="9956800" y="4622800"/>
+            <a:ext cx="1854200" cy="1854200"/>
+          </a:xfrm>
+          <a:prstGeom prst="ellipse">
+            <a:avLst/>
+          </a:prstGeom>
+        </p:spPr>
+      </p:pic>
+      <p:sp>
+        <p:nvSpPr>
+          <p:cNvPr id="7" name="next-card"/>
           <p:cNvSpPr/>
           <p:nvPr/>
         </p:nvSpPr>
@@ -8336,7 +9018,7 @@
       </p:sp>
       <p:sp>
         <p:nvSpPr>
-          <p:cNvPr id="6" name="Episode"/>
+          <p:cNvPr id="8" name="Episode"/>
           <p:cNvSpPr>
             <a:spLocks noGrp="1"/>
           </p:cNvSpPr>
@@ -8390,7 +9072,7 @@
       </p:sp>
       <p:sp>
         <p:nvSpPr>
-          <p:cNvPr id="7" name="Kicker"/>
+          <p:cNvPr id="9" name="Kicker"/>
           <p:cNvSpPr>
             <a:spLocks noGrp="1"/>
           </p:cNvSpPr>
@@ -8444,7 +9126,7 @@
       </p:sp>
       <p:sp>
         <p:nvSpPr>
-          <p:cNvPr id="8" name="Title"/>
+          <p:cNvPr id="10" name="Title"/>
           <p:cNvSpPr>
             <a:spLocks noGrp="1"/>
           </p:cNvSpPr>
@@ -8498,7 +9180,7 @@
       </p:sp>
       <p:sp>
         <p:nvSpPr>
-          <p:cNvPr id="9" name="NextLabel"/>
+          <p:cNvPr id="11" name="NextLabel"/>
           <p:cNvSpPr>
             <a:spLocks noGrp="1"/>
           </p:cNvSpPr>
@@ -8552,7 +9234,7 @@
       </p:sp>
       <p:sp>
         <p:nvSpPr>
-          <p:cNvPr id="10" name="NextTitle"/>
+          <p:cNvPr id="12" name="NextTitle"/>
           <p:cNvSpPr>
             <a:spLocks noGrp="1"/>
           </p:cNvSpPr>
@@ -8606,7 +9288,7 @@
       </p:sp>
       <p:sp>
         <p:nvSpPr>
-          <p:cNvPr id="11" name="NextText"/>
+          <p:cNvPr id="13" name="NextText"/>
           <p:cNvSpPr>
             <a:spLocks noGrp="1"/>
           </p:cNvSpPr>
@@ -8781,7 +9463,69 @@
       </p:pic>
       <p:sp>
         <p:nvSpPr>
-          <p:cNvPr id="5" name="Episode"/>
+          <p:cNvPr id="5" name="zone-ring"/>
+          <p:cNvSpPr/>
+          <p:nvPr/>
+        </p:nvSpPr>
+        <p:spPr>
+          <a:xfrm>
+            <a:off x="9931400" y="4597400"/>
+            <a:ext cx="1905000" cy="1905000"/>
+          </a:xfrm>
+          <a:prstGeom prst="ellipse">
+            <a:avLst/>
+          </a:prstGeom>
+          <a:solidFill>
+            <a:srgbClr val="FFFFFF"/>
+          </a:solidFill>
+          <a:ln w="25400">
+            <a:solidFill>
+              <a:srgbClr val="00A5FF"/>
+            </a:solidFill>
+          </a:ln>
+          <a:effectLst>
+            <a:glow rad="292100">
+              <a:srgbClr val="00A5FF">
+                <a:alpha val="45000"/>
+              </a:srgbClr>
+            </a:glow>
+          </a:effectLst>
+        </p:spPr>
+        <p:txBody>
+          <a:bodyPr rtlCol="0" anchor="ctr"/>
+          <a:lstStyle/>
+          <a:p>
+            <a:pPr algn="ctr"/>
+          </a:p>
+        </p:txBody>
+      </p:sp>
+      <p:pic>
+        <p:nvPicPr>
+          <p:cNvPr id="6" name="zone-presenter" descr="video-presenter.jpg"/>
+          <p:cNvPicPr>
+            <a:picLocks noChangeAspect="1"/>
+          </p:cNvPicPr>
+          <p:nvPr/>
+        </p:nvPicPr>
+        <p:blipFill>
+          <a:blip r:embed="rId3"/>
+          <a:stretch>
+            <a:fillRect/>
+          </a:stretch>
+        </p:blipFill>
+        <p:spPr>
+          <a:xfrm>
+            <a:off x="9956800" y="4622800"/>
+            <a:ext cx="1854200" cy="1854200"/>
+          </a:xfrm>
+          <a:prstGeom prst="ellipse">
+            <a:avLst/>
+          </a:prstGeom>
+        </p:spPr>
+      </p:pic>
+      <p:sp>
+        <p:nvSpPr>
+          <p:cNvPr id="7" name="Episode"/>
           <p:cNvSpPr>
             <a:spLocks noGrp="1"/>
           </p:cNvSpPr>
@@ -8835,7 +9579,7 @@
       </p:sp>
       <p:sp>
         <p:nvSpPr>
-          <p:cNvPr id="6" name="Kicker"/>
+          <p:cNvPr id="8" name="Kicker"/>
           <p:cNvSpPr>
             <a:spLocks noGrp="1"/>
           </p:cNvSpPr>
@@ -8889,7 +9633,7 @@
       </p:sp>
       <p:sp>
         <p:nvSpPr>
-          <p:cNvPr id="7" name="Title"/>
+          <p:cNvPr id="9" name="Title"/>
           <p:cNvSpPr>
             <a:spLocks noGrp="1"/>
           </p:cNvSpPr>
@@ -8943,7 +9687,7 @@
       </p:sp>
       <p:sp>
         <p:nvSpPr>
-          <p:cNvPr id="8" name="Points"/>
+          <p:cNvPr id="10" name="Points"/>
           <p:cNvSpPr>
             <a:spLocks noGrp="1"/>
           </p:cNvSpPr>
@@ -9145,7 +9889,69 @@
       </p:pic>
       <p:sp>
         <p:nvSpPr>
-          <p:cNvPr id="5" name="Episode"/>
+          <p:cNvPr id="5" name="zone-ring"/>
+          <p:cNvSpPr/>
+          <p:nvPr/>
+        </p:nvSpPr>
+        <p:spPr>
+          <a:xfrm>
+            <a:off x="9931400" y="4597400"/>
+            <a:ext cx="1905000" cy="1905000"/>
+          </a:xfrm>
+          <a:prstGeom prst="ellipse">
+            <a:avLst/>
+          </a:prstGeom>
+          <a:solidFill>
+            <a:srgbClr val="FFFFFF"/>
+          </a:solidFill>
+          <a:ln w="25400">
+            <a:solidFill>
+              <a:srgbClr val="00A5FF"/>
+            </a:solidFill>
+          </a:ln>
+          <a:effectLst>
+            <a:glow rad="292100">
+              <a:srgbClr val="00A5FF">
+                <a:alpha val="45000"/>
+              </a:srgbClr>
+            </a:glow>
+          </a:effectLst>
+        </p:spPr>
+        <p:txBody>
+          <a:bodyPr rtlCol="0" anchor="ctr"/>
+          <a:lstStyle/>
+          <a:p>
+            <a:pPr algn="ctr"/>
+          </a:p>
+        </p:txBody>
+      </p:sp>
+      <p:pic>
+        <p:nvPicPr>
+          <p:cNvPr id="6" name="zone-presenter" descr="video-presenter.jpg"/>
+          <p:cNvPicPr>
+            <a:picLocks noChangeAspect="1"/>
+          </p:cNvPicPr>
+          <p:nvPr/>
+        </p:nvPicPr>
+        <p:blipFill>
+          <a:blip r:embed="rId3"/>
+          <a:stretch>
+            <a:fillRect/>
+          </a:stretch>
+        </p:blipFill>
+        <p:spPr>
+          <a:xfrm>
+            <a:off x="9956800" y="4622800"/>
+            <a:ext cx="1854200" cy="1854200"/>
+          </a:xfrm>
+          <a:prstGeom prst="ellipse">
+            <a:avLst/>
+          </a:prstGeom>
+        </p:spPr>
+      </p:pic>
+      <p:sp>
+        <p:nvSpPr>
+          <p:cNvPr id="7" name="Episode"/>
           <p:cNvSpPr>
             <a:spLocks noGrp="1"/>
           </p:cNvSpPr>
@@ -9199,7 +10005,7 @@
       </p:sp>
       <p:sp>
         <p:nvSpPr>
-          <p:cNvPr id="6" name="Kicker"/>
+          <p:cNvPr id="8" name="Kicker"/>
           <p:cNvSpPr>
             <a:spLocks noGrp="1"/>
           </p:cNvSpPr>
@@ -9253,7 +10059,7 @@
       </p:sp>
       <p:sp>
         <p:nvSpPr>
-          <p:cNvPr id="7" name="Title"/>
+          <p:cNvPr id="9" name="Title"/>
           <p:cNvSpPr>
             <a:spLocks noGrp="1"/>
           </p:cNvSpPr>
@@ -9307,7 +10113,7 @@
       </p:sp>
       <p:sp>
         <p:nvSpPr>
-          <p:cNvPr id="8" name="Points"/>
+          <p:cNvPr id="10" name="Points"/>
           <p:cNvSpPr>
             <a:spLocks noGrp="1"/>
           </p:cNvSpPr>
@@ -9388,7 +10194,7 @@
       </p:sp>
       <p:sp>
         <p:nvSpPr>
-          <p:cNvPr id="9" name="Photo"/>
+          <p:cNvPr id="11" name="Photo"/>
           <p:cNvSpPr>
             <a:spLocks noGrp="1"/>
           </p:cNvSpPr>
@@ -9444,7 +10250,7 @@
       </p:sp>
       <p:sp>
         <p:nvSpPr>
-          <p:cNvPr id="10" name="Caption"/>
+          <p:cNvPr id="12" name="Caption"/>
           <p:cNvSpPr>
             <a:spLocks noGrp="1"/>
           </p:cNvSpPr>
@@ -9619,7 +10425,69 @@
       </p:pic>
       <p:sp>
         <p:nvSpPr>
-          <p:cNvPr id="5" name="Episode"/>
+          <p:cNvPr id="5" name="zone-ring"/>
+          <p:cNvSpPr/>
+          <p:nvPr/>
+        </p:nvSpPr>
+        <p:spPr>
+          <a:xfrm>
+            <a:off x="9931400" y="4597400"/>
+            <a:ext cx="1905000" cy="1905000"/>
+          </a:xfrm>
+          <a:prstGeom prst="ellipse">
+            <a:avLst/>
+          </a:prstGeom>
+          <a:solidFill>
+            <a:srgbClr val="FFFFFF"/>
+          </a:solidFill>
+          <a:ln w="25400">
+            <a:solidFill>
+              <a:srgbClr val="00A5FF"/>
+            </a:solidFill>
+          </a:ln>
+          <a:effectLst>
+            <a:glow rad="292100">
+              <a:srgbClr val="00A5FF">
+                <a:alpha val="45000"/>
+              </a:srgbClr>
+            </a:glow>
+          </a:effectLst>
+        </p:spPr>
+        <p:txBody>
+          <a:bodyPr rtlCol="0" anchor="ctr"/>
+          <a:lstStyle/>
+          <a:p>
+            <a:pPr algn="ctr"/>
+          </a:p>
+        </p:txBody>
+      </p:sp>
+      <p:pic>
+        <p:nvPicPr>
+          <p:cNvPr id="6" name="zone-presenter" descr="video-presenter.jpg"/>
+          <p:cNvPicPr>
+            <a:picLocks noChangeAspect="1"/>
+          </p:cNvPicPr>
+          <p:nvPr/>
+        </p:nvPicPr>
+        <p:blipFill>
+          <a:blip r:embed="rId3"/>
+          <a:stretch>
+            <a:fillRect/>
+          </a:stretch>
+        </p:blipFill>
+        <p:spPr>
+          <a:xfrm>
+            <a:off x="9956800" y="4622800"/>
+            <a:ext cx="1854200" cy="1854200"/>
+          </a:xfrm>
+          <a:prstGeom prst="ellipse">
+            <a:avLst/>
+          </a:prstGeom>
+        </p:spPr>
+      </p:pic>
+      <p:sp>
+        <p:nvSpPr>
+          <p:cNvPr id="7" name="Episode"/>
           <p:cNvSpPr>
             <a:spLocks noGrp="1"/>
           </p:cNvSpPr>
@@ -9673,7 +10541,7 @@
       </p:sp>
       <p:sp>
         <p:nvSpPr>
-          <p:cNvPr id="6" name="Kicker"/>
+          <p:cNvPr id="8" name="Kicker"/>
           <p:cNvSpPr>
             <a:spLocks noGrp="1"/>
           </p:cNvSpPr>
@@ -9727,7 +10595,7 @@
       </p:sp>
       <p:sp>
         <p:nvSpPr>
-          <p:cNvPr id="7" name="Title"/>
+          <p:cNvPr id="9" name="Title"/>
           <p:cNvSpPr>
             <a:spLocks noGrp="1"/>
           </p:cNvSpPr>
@@ -9781,7 +10649,7 @@
       </p:sp>
       <p:sp>
         <p:nvSpPr>
-          <p:cNvPr id="8" name="Points"/>
+          <p:cNvPr id="10" name="Points"/>
           <p:cNvSpPr>
             <a:spLocks noGrp="1"/>
           </p:cNvSpPr>
@@ -9983,7 +10851,69 @@
       </p:pic>
       <p:sp>
         <p:nvSpPr>
-          <p:cNvPr id="5" name="Episode"/>
+          <p:cNvPr id="5" name="zone-ring"/>
+          <p:cNvSpPr/>
+          <p:nvPr/>
+        </p:nvSpPr>
+        <p:spPr>
+          <a:xfrm>
+            <a:off x="9931400" y="4597400"/>
+            <a:ext cx="1905000" cy="1905000"/>
+          </a:xfrm>
+          <a:prstGeom prst="ellipse">
+            <a:avLst/>
+          </a:prstGeom>
+          <a:solidFill>
+            <a:srgbClr val="FFFFFF"/>
+          </a:solidFill>
+          <a:ln w="25400">
+            <a:solidFill>
+              <a:srgbClr val="00A5FF"/>
+            </a:solidFill>
+          </a:ln>
+          <a:effectLst>
+            <a:glow rad="292100">
+              <a:srgbClr val="00A5FF">
+                <a:alpha val="45000"/>
+              </a:srgbClr>
+            </a:glow>
+          </a:effectLst>
+        </p:spPr>
+        <p:txBody>
+          <a:bodyPr rtlCol="0" anchor="ctr"/>
+          <a:lstStyle/>
+          <a:p>
+            <a:pPr algn="ctr"/>
+          </a:p>
+        </p:txBody>
+      </p:sp>
+      <p:pic>
+        <p:nvPicPr>
+          <p:cNvPr id="6" name="zone-presenter" descr="video-presenter.jpg"/>
+          <p:cNvPicPr>
+            <a:picLocks noChangeAspect="1"/>
+          </p:cNvPicPr>
+          <p:nvPr/>
+        </p:nvPicPr>
+        <p:blipFill>
+          <a:blip r:embed="rId3"/>
+          <a:stretch>
+            <a:fillRect/>
+          </a:stretch>
+        </p:blipFill>
+        <p:spPr>
+          <a:xfrm>
+            <a:off x="9956800" y="4622800"/>
+            <a:ext cx="1854200" cy="1854200"/>
+          </a:xfrm>
+          <a:prstGeom prst="ellipse">
+            <a:avLst/>
+          </a:prstGeom>
+        </p:spPr>
+      </p:pic>
+      <p:sp>
+        <p:nvSpPr>
+          <p:cNvPr id="7" name="Episode"/>
           <p:cNvSpPr>
             <a:spLocks noGrp="1"/>
           </p:cNvSpPr>
@@ -10037,7 +10967,7 @@
       </p:sp>
       <p:sp>
         <p:nvSpPr>
-          <p:cNvPr id="6" name="Kicker"/>
+          <p:cNvPr id="8" name="Kicker"/>
           <p:cNvSpPr>
             <a:spLocks noGrp="1"/>
           </p:cNvSpPr>
@@ -10091,7 +11021,7 @@
       </p:sp>
       <p:sp>
         <p:nvSpPr>
-          <p:cNvPr id="7" name="Big"/>
+          <p:cNvPr id="9" name="Big"/>
           <p:cNvSpPr>
             <a:spLocks noGrp="1"/>
           </p:cNvSpPr>
@@ -10148,7 +11078,7 @@
       </p:sp>
       <p:sp>
         <p:nvSpPr>
-          <p:cNvPr id="8" name="Statement"/>
+          <p:cNvPr id="10" name="Statement"/>
           <p:cNvSpPr>
             <a:spLocks noGrp="1"/>
           </p:cNvSpPr>
@@ -10202,7 +11132,7 @@
       </p:sp>
       <p:sp>
         <p:nvSpPr>
-          <p:cNvPr id="9" name="Text"/>
+          <p:cNvPr id="11" name="Text"/>
           <p:cNvSpPr>
             <a:spLocks noGrp="1"/>
           </p:cNvSpPr>
@@ -10377,7 +11307,69 @@
       </p:pic>
       <p:sp>
         <p:nvSpPr>
-          <p:cNvPr id="5" name="Episode"/>
+          <p:cNvPr id="5" name="zone-ring"/>
+          <p:cNvSpPr/>
+          <p:nvPr/>
+        </p:nvSpPr>
+        <p:spPr>
+          <a:xfrm>
+            <a:off x="9931400" y="4597400"/>
+            <a:ext cx="1905000" cy="1905000"/>
+          </a:xfrm>
+          <a:prstGeom prst="ellipse">
+            <a:avLst/>
+          </a:prstGeom>
+          <a:solidFill>
+            <a:srgbClr val="FFFFFF"/>
+          </a:solidFill>
+          <a:ln w="25400">
+            <a:solidFill>
+              <a:srgbClr val="00A5FF"/>
+            </a:solidFill>
+          </a:ln>
+          <a:effectLst>
+            <a:glow rad="292100">
+              <a:srgbClr val="00A5FF">
+                <a:alpha val="45000"/>
+              </a:srgbClr>
+            </a:glow>
+          </a:effectLst>
+        </p:spPr>
+        <p:txBody>
+          <a:bodyPr rtlCol="0" anchor="ctr"/>
+          <a:lstStyle/>
+          <a:p>
+            <a:pPr algn="ctr"/>
+          </a:p>
+        </p:txBody>
+      </p:sp>
+      <p:pic>
+        <p:nvPicPr>
+          <p:cNvPr id="6" name="zone-presenter" descr="video-presenter.jpg"/>
+          <p:cNvPicPr>
+            <a:picLocks noChangeAspect="1"/>
+          </p:cNvPicPr>
+          <p:nvPr/>
+        </p:nvPicPr>
+        <p:blipFill>
+          <a:blip r:embed="rId3"/>
+          <a:stretch>
+            <a:fillRect/>
+          </a:stretch>
+        </p:blipFill>
+        <p:spPr>
+          <a:xfrm>
+            <a:off x="9956800" y="4622800"/>
+            <a:ext cx="1854200" cy="1854200"/>
+          </a:xfrm>
+          <a:prstGeom prst="ellipse">
+            <a:avLst/>
+          </a:prstGeom>
+        </p:spPr>
+      </p:pic>
+      <p:sp>
+        <p:nvSpPr>
+          <p:cNvPr id="7" name="Episode"/>
           <p:cNvSpPr>
             <a:spLocks noGrp="1"/>
           </p:cNvSpPr>
@@ -10431,7 +11423,7 @@
       </p:sp>
       <p:sp>
         <p:nvSpPr>
-          <p:cNvPr id="6" name="Kicker"/>
+          <p:cNvPr id="8" name="Kicker"/>
           <p:cNvSpPr>
             <a:spLocks noGrp="1"/>
           </p:cNvSpPr>
@@ -10485,7 +11477,7 @@
       </p:sp>
       <p:sp>
         <p:nvSpPr>
-          <p:cNvPr id="7" name="Title"/>
+          <p:cNvPr id="9" name="Title"/>
           <p:cNvSpPr>
             <a:spLocks noGrp="1"/>
           </p:cNvSpPr>

</xml_diff>